<commit_message>
Slides: sd-05-005 cover title back to 108 px, PPTX re-exported
Co-Authored-By: Claude Opus 5.5 <noreply@anthropic.com>
Claude-Session: https://claude.ai/code/session_01C9pH8NnezrynRr5dznPeP3
</commit_message>
<xml_diff>
--- a/system-design-101/vi/lessons/sd-05-005/slides/sd-05-005.pptx
+++ b/system-design-101/vi/lessons/sd-05-005/slides/sd-05-005.pptx
@@ -1790,7 +1790,7 @@
         <p:spPr>
           <a:xfrm>
             <a:off x="914400" y="1428750"/>
-            <a:ext cx="16459200" cy="2190750"/>
+            <a:ext cx="16459200" cy="3600450"/>
           </a:xfrm>
           <a:prstGeom prst="rect">
             <a:avLst/>
@@ -1799,17 +1799,17 @@
           <a:ln/>
         </p:spPr>
         <p:txBody>
-          <a:bodyPr wrap="square" lIns="0" tIns="57799" rIns="0" bIns="-57799" rtlCol="0" anchor="t"/>
+          <a:bodyPr wrap="square" lIns="0" tIns="69437" rIns="0" bIns="-69437" rtlCol="0" anchor="t"/>
           <a:lstStyle/>
           <a:p>
             <a:pPr algn="l" indent="0" marL="0">
               <a:lnSpc>
-                <a:spcPts val="7079"/>
+                <a:spcPts val="8505"/>
               </a:lnSpc>
               <a:buNone/>
             </a:pPr>
             <a:r>
-              <a:rPr lang="en-US" sz="6742" dirty="0" spc="4" kern="0">
+              <a:rPr lang="en-US" sz="8100" dirty="0" spc="11" kern="0">
                 <a:solidFill>
                   <a:srgbClr val="F3EEE3"/>
                 </a:solidFill>
@@ -1820,7 +1820,7 @@
               <a:t>Ôn</a:t>
             </a:r>
             <a:r>
-              <a:rPr lang="en-US" sz="6742" dirty="0" spc="3" kern="0">
+              <a:rPr lang="en-US" sz="8100" dirty="0" spc="3" kern="0">
                 <a:solidFill>
                   <a:srgbClr val="F3EEE3"/>
                 </a:solidFill>
@@ -1831,7 +1831,7 @@
               <a:t> phỏng</a:t>
             </a:r>
             <a:r>
-              <a:rPr lang="en-US" sz="6742" dirty="0" spc="-53" kern="0">
+              <a:rPr lang="en-US" sz="8100" dirty="0" spc="-65" kern="0">
                 <a:solidFill>
                   <a:srgbClr val="F3EEE3"/>
                 </a:solidFill>
@@ -1842,7 +1842,7 @@
               <a:t> vấn</a:t>
             </a:r>
             <a:r>
-              <a:rPr lang="en-US" sz="6742" dirty="0" spc="0" kern="0">
+              <a:rPr lang="en-US" sz="8100" dirty="0" spc="-3" kern="0">
                 <a:solidFill>
                   <a:srgbClr val="F3EEE3"/>
                 </a:solidFill>
@@ -1853,7 +1853,7 @@
               <a:t> kỹ</a:t>
             </a:r>
             <a:r>
-              <a:rPr lang="en-US" sz="6742" dirty="0" spc="11" kern="0">
+              <a:rPr lang="en-US" sz="8100" dirty="0" spc="10" kern="0">
                 <a:solidFill>
                   <a:srgbClr val="F3EEE3"/>
                 </a:solidFill>
@@ -1864,7 +1864,7 @@
               <a:t> thuật:</a:t>
             </a:r>
             <a:r>
-              <a:rPr lang="en-US" sz="6742" dirty="0" spc="3" kern="0">
+              <a:rPr lang="en-US" sz="8100" dirty="0" spc="1" kern="0">
                 <a:solidFill>
                   <a:srgbClr val="F3EEE3"/>
                 </a:solidFill>
@@ -1875,7 +1875,7 @@
               <a:t> từ</a:t>
             </a:r>
             <a:r>
-              <a:rPr lang="en-US" sz="6742" dirty="0" spc="1" kern="0">
+              <a:rPr lang="en-US" sz="8100" dirty="0" spc="0" kern="0">
                 <a:solidFill>
                   <a:srgbClr val="F3EEE3"/>
                 </a:solidFill>
@@ -1886,7 +1886,7 @@
               <a:t> danh</a:t>
             </a:r>
             <a:r>
-              <a:rPr lang="en-US" sz="6742" dirty="0" spc="0" kern="0">
+              <a:rPr lang="en-US" sz="8100" dirty="0" spc="-1" kern="0">
                 <a:solidFill>
                   <a:srgbClr val="F3EEE3"/>
                 </a:solidFill>
@@ -1897,7 +1897,7 @@
               <a:t> sách</a:t>
             </a:r>
             <a:r>
-              <a:rPr lang="en-US" sz="6742" dirty="0" spc="-2" kern="0">
+              <a:rPr lang="en-US" sz="8100" dirty="0" spc="-7" kern="0">
                 <a:solidFill>
                   <a:srgbClr val="F3EEE3"/>
                 </a:solidFill>
@@ -1908,7 +1908,7 @@
               <a:t> tài</a:t>
             </a:r>
             <a:r>
-              <a:rPr lang="en-US" sz="6742" dirty="0" spc="7" kern="0">
+              <a:rPr lang="en-US" sz="8100" dirty="0" spc="2" kern="0">
                 <a:solidFill>
                   <a:srgbClr val="F3EEE3"/>
                 </a:solidFill>
@@ -1919,7 +1919,7 @@
               <a:t> liệu</a:t>
             </a:r>
             <a:r>
-              <a:rPr lang="en-US" sz="6742" dirty="0" spc="18" kern="0">
+              <a:rPr lang="en-US" sz="8100" dirty="0" spc="19" kern="0">
                 <a:solidFill>
                   <a:srgbClr val="F3EEE3"/>
                 </a:solidFill>
@@ -1930,7 +1930,7 @@
               <a:t> đến</a:t>
             </a:r>
             <a:r>
-              <a:rPr lang="en-US" sz="6742" dirty="0" spc="-52" kern="0">
+              <a:rPr lang="en-US" sz="8100" dirty="0" spc="-66" kern="0">
                 <a:solidFill>
                   <a:srgbClr val="F3EEE3"/>
                 </a:solidFill>
@@ -1941,7 +1941,7 @@
               <a:t> kế</a:t>
             </a:r>
             <a:r>
-              <a:rPr lang="en-US" sz="6742" dirty="0" spc="-5" kern="0">
+              <a:rPr lang="en-US" sz="8100" dirty="0" spc="-6" kern="0">
                 <a:solidFill>
                   <a:srgbClr val="F3EEE3"/>
                 </a:solidFill>
@@ -1952,7 +1952,7 @@
               <a:t> hoạch</a:t>
             </a:r>
             <a:r>
-              <a:rPr lang="en-US" sz="6742" dirty="0" spc="3" kern="0">
+              <a:rPr lang="en-US" sz="8100" dirty="0" spc="2" kern="0">
                 <a:solidFill>
                   <a:srgbClr val="F3EEE3"/>
                 </a:solidFill>
@@ -1962,7 +1962,7 @@
               </a:rPr>
               <a:t> luyện</a:t>
             </a:r>
-            <a:endParaRPr lang="en-US" sz="6742" dirty="0"/>
+            <a:endParaRPr lang="en-US" sz="8100" dirty="0"/>
           </a:p>
         </p:txBody>
       </p:sp>
@@ -1974,7 +1974,7 @@
         </p:nvSpPr>
         <p:spPr>
           <a:xfrm>
-            <a:off x="914400" y="3905250"/>
+            <a:off x="914400" y="5048250"/>
             <a:ext cx="16459200" cy="571500"/>
           </a:xfrm>
           <a:prstGeom prst="rect">
@@ -2112,7 +2112,7 @@
         </p:nvSpPr>
         <p:spPr>
           <a:xfrm>
-            <a:off x="914400" y="5334000"/>
+            <a:off x="914400" y="6096000"/>
             <a:ext cx="4000500" cy="2476500"/>
           </a:xfrm>
           <a:prstGeom prst="roundRect">
@@ -2139,7 +2139,7 @@
         </p:nvSpPr>
         <p:spPr>
           <a:xfrm>
-            <a:off x="1219200" y="5572125"/>
+            <a:off x="1219200" y="6334125"/>
             <a:ext cx="3390900" cy="857250"/>
           </a:xfrm>
           <a:prstGeom prst="rect">
@@ -2178,7 +2178,7 @@
         </p:nvSpPr>
         <p:spPr>
           <a:xfrm>
-            <a:off x="1219200" y="6572250"/>
+            <a:off x="1219200" y="7334250"/>
             <a:ext cx="3390900" cy="1047750"/>
           </a:xfrm>
           <a:prstGeom prst="rect">
@@ -2275,7 +2275,7 @@
         </p:nvSpPr>
         <p:spPr>
           <a:xfrm>
-            <a:off x="5143500" y="5334000"/>
+            <a:off x="5143500" y="6096000"/>
             <a:ext cx="4000500" cy="2476500"/>
           </a:xfrm>
           <a:prstGeom prst="roundRect">
@@ -2302,7 +2302,7 @@
         </p:nvSpPr>
         <p:spPr>
           <a:xfrm>
-            <a:off x="5448300" y="5572125"/>
+            <a:off x="5448300" y="6334125"/>
             <a:ext cx="3390900" cy="857250"/>
           </a:xfrm>
           <a:prstGeom prst="rect">
@@ -2341,7 +2341,7 @@
         </p:nvSpPr>
         <p:spPr>
           <a:xfrm>
-            <a:off x="5448300" y="6572250"/>
+            <a:off x="5448300" y="7334250"/>
             <a:ext cx="3390900" cy="1047750"/>
           </a:xfrm>
           <a:prstGeom prst="rect">
@@ -2438,7 +2438,7 @@
         </p:nvSpPr>
         <p:spPr>
           <a:xfrm>
-            <a:off x="9372600" y="5334000"/>
+            <a:off x="9372600" y="6096000"/>
             <a:ext cx="4000500" cy="2476500"/>
           </a:xfrm>
           <a:prstGeom prst="roundRect">
@@ -2465,7 +2465,7 @@
         </p:nvSpPr>
         <p:spPr>
           <a:xfrm>
-            <a:off x="9677400" y="5572125"/>
+            <a:off x="9677400" y="6334125"/>
             <a:ext cx="3390900" cy="857250"/>
           </a:xfrm>
           <a:prstGeom prst="rect">
@@ -2504,7 +2504,7 @@
         </p:nvSpPr>
         <p:spPr>
           <a:xfrm>
-            <a:off x="9677400" y="6572250"/>
+            <a:off x="9677400" y="7334250"/>
             <a:ext cx="3390900" cy="1047750"/>
           </a:xfrm>
           <a:prstGeom prst="rect">
@@ -2579,7 +2579,7 @@
         </p:nvSpPr>
         <p:spPr>
           <a:xfrm>
-            <a:off x="13601700" y="5334000"/>
+            <a:off x="13601700" y="6096000"/>
             <a:ext cx="4000500" cy="2476500"/>
           </a:xfrm>
           <a:prstGeom prst="roundRect">
@@ -2606,7 +2606,7 @@
         </p:nvSpPr>
         <p:spPr>
           <a:xfrm>
-            <a:off x="13906500" y="5572125"/>
+            <a:off x="13906500" y="6334125"/>
             <a:ext cx="3390900" cy="857250"/>
           </a:xfrm>
           <a:prstGeom prst="rect">
@@ -2645,7 +2645,7 @@
         </p:nvSpPr>
         <p:spPr>
           <a:xfrm>
-            <a:off x="13906500" y="6572250"/>
+            <a:off x="13906500" y="7334250"/>
             <a:ext cx="3390900" cy="1047750"/>
           </a:xfrm>
           <a:prstGeom prst="rect">

</xml_diff>

<commit_message>
Slides: sd-05-005 cover names both ideas of the first concept
Co-Authored-By: Claude Opus 5.5 <noreply@anthropic.com>
Claude-Session: https://claude.ai/code/session_01C9pH8NnezrynRr5dznPeP3
</commit_message>
<xml_diff>
--- a/system-design-101/vi/lessons/sd-05-005/slides/sd-05-005.pptx
+++ b/system-design-101/vi/lessons/sd-05-005/slides/sd-05-005.pptx
@@ -2187,7 +2187,7 @@
               <a:buNone/>
             </a:pPr>
             <a:r>
-              <a:rPr lang="en-US" sz="2400" b="1" dirty="0" spc="-44" kern="0">
+              <a:rPr lang="en-US" sz="2400" b="1" dirty="0" spc="-8" kern="0">
                 <a:solidFill>
                   <a:srgbClr val="F3EEE3"/>
                 </a:solidFill>
@@ -2195,10 +2195,10 @@
                 <a:ea typeface="Be Vietnam Pro" pitchFamily="34" charset="-122"/>
                 <a:cs typeface="Be Vietnam Pro" pitchFamily="34" charset="-120"/>
               </a:rPr>
-              <a:t>Vòng</a:t>
-            </a:r>
-            <a:r>
-              <a:rPr lang="en-US" sz="2400" b="1" dirty="0" spc="2" kern="0">
+              <a:t>Chọn</a:t>
+            </a:r>
+            <a:r>
+              <a:rPr lang="en-US" sz="2400" b="1" dirty="0" spc="-19" kern="0">
                 <a:solidFill>
                   <a:srgbClr val="F3EEE3"/>
                 </a:solidFill>
@@ -2206,7 +2206,7 @@
                 <a:ea typeface="Be Vietnam Pro" pitchFamily="34" charset="-122"/>
                 <a:cs typeface="Be Vietnam Pro" pitchFamily="34" charset="-120"/>
               </a:rPr>
-              <a:t> nào</a:t>
+              <a:t> vòng</a:t>
             </a:r>
             <a:r>
               <a:rPr lang="en-US" sz="2400" b="1" dirty="0" spc="9" kern="0">
@@ -2217,7 +2217,7 @@
                 <a:ea typeface="Be Vietnam Pro" pitchFamily="34" charset="-122"/>
                 <a:cs typeface="Be Vietnam Pro" pitchFamily="34" charset="-120"/>
               </a:rPr>
-              <a:t> trước,</a:t>
+              <a:t> trước;</a:t>
             </a:r>
             <a:r>
               <a:rPr lang="en-US" sz="2400" b="1" dirty="0" spc="-3" kern="0">
@@ -2228,10 +2228,10 @@
                 <a:ea typeface="Be Vietnam Pro" pitchFamily="34" charset="-122"/>
                 <a:cs typeface="Be Vietnam Pro" pitchFamily="34" charset="-120"/>
               </a:rPr>
-              <a:t> tài</a:t>
-            </a:r>
-            <a:r>
-              <a:rPr lang="en-US" sz="2400" b="1" dirty="0" spc="0" kern="0">
+              <a:t> mỗi</a:t>
+            </a:r>
+            <a:r>
+              <a:rPr lang="en-US" sz="2400" b="1" dirty="0" spc="-18" kern="0">
                 <a:solidFill>
                   <a:srgbClr val="F3EEE3"/>
                 </a:solidFill>
@@ -2239,10 +2239,10 @@
                 <a:ea typeface="Be Vietnam Pro" pitchFamily="34" charset="-122"/>
                 <a:cs typeface="Be Vietnam Pro" pitchFamily="34" charset="-120"/>
               </a:rPr>
-              <a:t> liệu</a:t>
-            </a:r>
-            <a:r>
-              <a:rPr lang="en-US" sz="2400" b="1" dirty="0" spc="3" kern="0">
+              <a:t> vòng</a:t>
+            </a:r>
+            <a:r>
+              <a:rPr lang="en-US" sz="2400" b="1" dirty="0" spc="-17" kern="0">
                 <a:solidFill>
                   <a:srgbClr val="F3EEE3"/>
                 </a:solidFill>
@@ -2250,7 +2250,29 @@
                 <a:ea typeface="Be Vietnam Pro" pitchFamily="34" charset="-122"/>
                 <a:cs typeface="Be Vietnam Pro" pitchFamily="34" charset="-120"/>
               </a:rPr>
-              <a:t> sau</a:t>
+              <a:t> luyện</a:t>
+            </a:r>
+            <a:r>
+              <a:rPr lang="en-US" sz="2400" b="1" dirty="0" spc="-7" kern="0">
+                <a:solidFill>
+                  <a:srgbClr val="F3EEE3"/>
+                </a:solidFill>
+                <a:latin typeface="Be Vietnam Pro" pitchFamily="34" charset="0"/>
+                <a:ea typeface="Be Vietnam Pro" pitchFamily="34" charset="-122"/>
+                <a:cs typeface="Be Vietnam Pro" pitchFamily="34" charset="-120"/>
+              </a:rPr>
+              <a:t> một</a:t>
+            </a:r>
+            <a:r>
+              <a:rPr lang="en-US" sz="2400" b="1" dirty="0" spc="-1" kern="0">
+                <a:solidFill>
+                  <a:srgbClr val="F3EEE3"/>
+                </a:solidFill>
+                <a:latin typeface="Be Vietnam Pro" pitchFamily="34" charset="0"/>
+                <a:ea typeface="Be Vietnam Pro" pitchFamily="34" charset="-122"/>
+                <a:cs typeface="Be Vietnam Pro" pitchFamily="34" charset="-120"/>
+              </a:rPr>
+              <a:t> kiểu</a:t>
             </a:r>
             <a:endParaRPr lang="en-US" sz="2400" dirty="0"/>
           </a:p>

</xml_diff>